<commit_message>
Pipeline: drop dollars for Next Action; add "return to problem" + 5th verb
- Who We Pursue: remove revenue/weighted-value estimates (false precision)
  in favor of Target · Relationship · Probability · Next Action.
- Language tab: add "always return to the problem" guardrail — never use
  Institutional Stewardship by itself; tie it to turnover, lost knowledge,
  stalled projects, missed opportunities.
- Five layers, five verbs: Understand · Navigate · Diagnose · Deliver ·
  Sustain. Start Here architecture line + The Path foundation bar updated.
Refresh the v1 stack zip.

https://claude.ai/code/session_01NNVRfcBeiW4jRftzrwemzW
</commit_message>
<xml_diff>
--- a/docs/business/final_deck/PublicLogic - The Path (one-page visual).pptx
+++ b/docs/business/final_deck/PublicLogic - The Path (one-page visual).pptx
@@ -4465,6 +4465,15 @@
                 <a:latin typeface="Helvetica Neue"/>
               </a:rPr>
               <a:t>CONTINUITY &amp; STEWARDSHIP SYSTEMS   </a:t>
+            </a:r>
+            <a:r>
+              <a:rPr sz="1200" b="1" i="0">
+                <a:solidFill>
+                  <a:srgbClr val="D8C89A"/>
+                </a:solidFill>
+                <a:latin typeface="Helvetica Neue"/>
+              </a:rPr>
+              <a:t>· SUSTAIN ·   </a:t>
             </a:r>
             <a:r>
               <a:rPr sz="1200" b="0" i="1">

</xml_diff>